<commit_message>
add lab 6 (Conditional DDPM): source code, report, generated images; update README and .gitignore
- Conditional DDPM with UNet2D + CFG; test acc 0.88, new_test acc 0.90
- Update .gitignore to allow lab 6 generated PNG images
- Add Lab 6 section to README

Co-Authored-By: Claude Sonnet 4.6 <noreply@anthropic.com>
</commit_message>
<xml_diff>
--- a/lab 6/Lab6_Generative_Models.pptx
+++ b/lab 6/Lab6_Generative_Models.pptx
@@ -34,24 +34,31 @@
   <p:notesSz cx="6858000" cy="9144000"/>
   <p:embeddedFontLst>
     <p:embeddedFont>
-      <p:font typeface="Libre Baskerville" panose="02000000000000000000" pitchFamily="2" charset="0"/>
+      <p:font typeface="Libre Baskerville" panose="02020500000000000000" charset="0"/>
       <p:regular r:id="rId24"/>
       <p:bold r:id="rId25"/>
       <p:italic r:id="rId26"/>
     </p:embeddedFont>
     <p:embeddedFont>
-      <p:font typeface="Libre Franklin" pitchFamily="2" charset="0"/>
+      <p:font typeface="Calibri" panose="020F0502020204030204" pitchFamily="34" charset="0"/>
       <p:regular r:id="rId27"/>
       <p:bold r:id="rId28"/>
       <p:italic r:id="rId29"/>
       <p:boldItalic r:id="rId30"/>
     </p:embeddedFont>
     <p:embeddedFont>
-      <p:font typeface="Times" panose="02020603050405020304" pitchFamily="18" charset="0"/>
+      <p:font typeface="Libre Franklin" panose="02020500000000000000" charset="0"/>
       <p:regular r:id="rId31"/>
       <p:bold r:id="rId32"/>
       <p:italic r:id="rId33"/>
       <p:boldItalic r:id="rId34"/>
+    </p:embeddedFont>
+    <p:embeddedFont>
+      <p:font typeface="Times" panose="02020603050405020304" pitchFamily="18" charset="0"/>
+      <p:regular r:id="rId35"/>
+      <p:bold r:id="rId36"/>
+      <p:italic r:id="rId37"/>
+      <p:boldItalic r:id="rId38"/>
     </p:embeddedFont>
   </p:embeddedFontLst>
   <p:defaultTextStyle>
@@ -288,7 +295,7 @@
       <p15:sldGuideLst xmlns:p15="http://schemas.microsoft.com/office/powerpoint/2012/main"/>
     </p:ext>
     <p:ext uri="GoogleSlidesCustomDataVersion2">
-      <go:slidesCustomData xmlns:go="http://customooxmlschemas.google.com/" xmlns:ahyp="http://schemas.microsoft.com/office/drawing/2018/hyperlinkcolor" xmlns:p15="http://schemas.microsoft.com/office/powerpoint/2012/main" xmlns:p14="http://schemas.microsoft.com/office/powerpoint/2010/main" xmlns:com="http://schemas.openxmlformats.org/drawingml/2006/compatibility" xmlns:pvml="urn:schemas-microsoft-com:office:powerpoint" xmlns:v="urn:schemas-microsoft-com:vml" xmlns:o="urn:schemas-microsoft-com:office:office" xmlns:dgm="http://schemas.openxmlformats.org/drawingml/2006/diagram" xmlns:c="http://schemas.openxmlformats.org/drawingml/2006/chart" xmlns:mv="urn:schemas-microsoft-com:mac:vml" xmlns:mc="http://schemas.openxmlformats.org/markup-compatibility/2006" xmlns="" r:id="rId35" roundtripDataSignature="AMtx7mhnOB+ynUX9uT2O2/6WadvcGy9TOg=="/>
+      <go:slidesCustomData xmlns="" xmlns:mc="http://schemas.openxmlformats.org/markup-compatibility/2006" xmlns:mv="urn:schemas-microsoft-com:mac:vml" xmlns:c="http://schemas.openxmlformats.org/drawingml/2006/chart" xmlns:dgm="http://schemas.openxmlformats.org/drawingml/2006/diagram" xmlns:o="urn:schemas-microsoft-com:office:office" xmlns:v="urn:schemas-microsoft-com:vml" xmlns:pvml="urn:schemas-microsoft-com:office:powerpoint" xmlns:com="http://schemas.openxmlformats.org/drawingml/2006/compatibility" xmlns:p14="http://schemas.microsoft.com/office/powerpoint/2010/main" xmlns:p15="http://schemas.microsoft.com/office/powerpoint/2012/main" xmlns:ahyp="http://schemas.microsoft.com/office/drawing/2018/hyperlinkcolor" xmlns:go="http://customooxmlschemas.google.com/" r:id="rId39" roundtripDataSignature="AMtx7mhnOB+ynUX9uT2O2/6WadvcGy9TOg=="/>
     </p:ext>
   </p:extLst>
 </p:presentation>

</xml_diff>